<commit_message>
feat: overhaul README with scientific visuals, academic PDF suite, and faculty evaluation guide
</commit_message>
<xml_diff>
--- a/reports/presentation/seismic_ai_presentation.pptx
+++ b/reports/presentation/seismic_ai_presentation.pptx
@@ -3316,7 +3316,7 @@
               </a:defRPr>
             </a:pPr>
             <a:r>
-              <a:t>Candidate: Rahul  |  Focus Area: Computational Mechanics, PBEE &amp; Surrogate ML</a:t>
+              <a:t>Candidate: Raghvendra Singh Gahlot  |  Civil Engineering, MBM University</a:t>
             </a:r>
           </a:p>
           <a:p>
@@ -3328,7 +3328,7 @@
               </a:defRPr>
             </a:pPr>
             <a:r>
-              <a:t>Target Review: Department of Civil Engineering, Indian Institute of Technology Delhi (IIT Delhi)</a:t>
+              <a:t>Contact: raghvendra1gdsc@gmail.com  |  GitHub: github.com/raghvendra1gdsc-png</a:t>
             </a:r>
           </a:p>
           <a:p>
@@ -4264,7 +4264,7 @@
               </a:defRPr>
             </a:pPr>
             <a:r>
-              <a:t>Conclusions &amp; Proposed Research at IIT Delhi</a:t>
+              <a:t>Conclusions &amp; Proposed Research Directions</a:t>
             </a:r>
           </a:p>
         </p:txBody>
@@ -4471,7 +4471,7 @@
               </a:defRPr>
             </a:pPr>
             <a:r>
-              <a:t>Proposed Internship Extensions at IIT Delhi</a:t>
+              <a:t>Proposed Internship Research Directions</a:t>
             </a:r>
           </a:p>
         </p:txBody>

</xml_diff>